<commit_message>
New demo files: designed Q3 board update pptx (native chart, speaker notes), Northwind seed deck (8 people vs the email's 7), scanned cap table PDF (image only; $15M incl. an August SAFE vs the deck's $12M); deck viewer is data-driven with an info panel, progress and activity; attachments preview in the viewer and download on hover; script uses download + drag from Chrome's downloads bubble
Co-Authored-By: Claude Opus 5.5 <noreply@anthropic.com>
</commit_message>
<xml_diff>
--- a/backend/samples/06_acme_board_update.pptx
+++ b/backend/samples/06_acme_board_update.pptx
@@ -9,8 +9,11 @@
     <p:sldId id="257" r:id="rId9"/>
     <p:sldId id="258" r:id="rId10"/>
     <p:sldId id="259" r:id="rId11"/>
+    <p:sldId id="260" r:id="rId12"/>
+    <p:sldId id="261" r:id="rId13"/>
+    <p:sldId id="262" r:id="rId14"/>
   </p:sldIdLst>
-  <p:sldSz cx="9144000" cy="6858000" type="screen4x3"/>
+  <p:sldSz cx="12192000" cy="6858000" type="screen4x3"/>
   <p:notesSz cx="6858000" cy="9144000"/>
   <p:defaultTextStyle>
     <a:defPPr>
@@ -108,6 +111,183 @@
     </a:lvl9pPr>
   </p:defaultTextStyle>
 </p:presentation>
+</file>
+
+<file path=ppt/charts/chart1.xml><?xml version="1.0" encoding="utf-8"?>
+<c:chartSpace xmlns:c="http://schemas.openxmlformats.org/drawingml/2006/chart" xmlns:a="http://schemas.openxmlformats.org/drawingml/2006/main" xmlns:r="http://schemas.openxmlformats.org/officeDocument/2006/relationships">
+  <c:date1904 val="0"/>
+  <c:chart>
+    <c:autoTitleDeleted val="0"/>
+    <c:plotArea>
+      <c:barChart>
+        <c:barDir val="col"/>
+        <c:grouping val="clustered"/>
+        <c:ser>
+          <c:idx val="0"/>
+          <c:order val="0"/>
+          <c:tx>
+            <c:strRef>
+              <c:f>Sheet1!$B$1</c:f>
+              <c:strCache>
+                <c:ptCount val="1"/>
+                <c:pt idx="0">
+                  <c:v>ARR ($M)</c:v>
+                </c:pt>
+              </c:strCache>
+            </c:strRef>
+          </c:tx>
+          <c:spPr>
+            <a:solidFill>
+              <a:srgbClr val="E0663A"/>
+            </a:solidFill>
+          </c:spPr>
+          <c:cat>
+            <c:strRef>
+              <c:f>Sheet1!$A$2:$A$11</c:f>
+              <c:strCache>
+                <c:ptCount val="10"/>
+                <c:pt idx="0">
+                  <c:v>Dec</c:v>
+                </c:pt>
+                <c:pt idx="1">
+                  <c:v>Jan</c:v>
+                </c:pt>
+                <c:pt idx="2">
+                  <c:v>Feb</c:v>
+                </c:pt>
+                <c:pt idx="3">
+                  <c:v>Mar</c:v>
+                </c:pt>
+                <c:pt idx="4">
+                  <c:v>Apr</c:v>
+                </c:pt>
+                <c:pt idx="5">
+                  <c:v>May</c:v>
+                </c:pt>
+                <c:pt idx="6">
+                  <c:v>Jun</c:v>
+                </c:pt>
+                <c:pt idx="7">
+                  <c:v>Jul</c:v>
+                </c:pt>
+                <c:pt idx="8">
+                  <c:v>Aug</c:v>
+                </c:pt>
+                <c:pt idx="9">
+                  <c:v>Sep</c:v>
+                </c:pt>
+              </c:strCache>
+            </c:strRef>
+          </c:cat>
+          <c:val>
+            <c:numRef>
+              <c:f>Sheet1!$B$2:$B$11</c:f>
+              <c:numCache>
+                <c:formatCode>General</c:formatCode>
+                <c:ptCount val="10"/>
+                <c:pt idx="0">
+                  <c:v>0.99</c:v>
+                </c:pt>
+                <c:pt idx="1">
+                  <c:v>1.17</c:v>
+                </c:pt>
+                <c:pt idx="2">
+                  <c:v>1.35</c:v>
+                </c:pt>
+                <c:pt idx="3">
+                  <c:v>1.51</c:v>
+                </c:pt>
+                <c:pt idx="4">
+                  <c:v>1.72</c:v>
+                </c:pt>
+                <c:pt idx="5">
+                  <c:v>1.92</c:v>
+                </c:pt>
+                <c:pt idx="6">
+                  <c:v>2.13</c:v>
+                </c:pt>
+                <c:pt idx="7">
+                  <c:v>2.29</c:v>
+                </c:pt>
+                <c:pt idx="8">
+                  <c:v>2.42</c:v>
+                </c:pt>
+                <c:pt idx="9">
+                  <c:v>2.6</c:v>
+                </c:pt>
+              </c:numCache>
+            </c:numRef>
+          </c:val>
+        </c:ser>
+        <c:gapWidth val="60"/>
+        <c:axId val="-2068027336"/>
+        <c:axId val="-2113994440"/>
+      </c:barChart>
+      <c:catAx>
+        <c:axId val="-2068027336"/>
+        <c:scaling>
+          <c:orientation val="minMax"/>
+        </c:scaling>
+        <c:delete val="0"/>
+        <c:axPos val="b"/>
+        <c:majorTickMark val="out"/>
+        <c:minorTickMark val="none"/>
+        <c:tickLblPos val="nextTo"/>
+        <c:spPr>
+          <a:ln>
+            <a:solidFill>
+              <a:srgbClr val="E6E2D9"/>
+            </a:solidFill>
+          </a:ln>
+        </c:spPr>
+        <c:txPr>
+          <a:bodyPr/>
+          <a:lstStyle/>
+          <a:p>
+            <a:pPr>
+              <a:defRPr sz="1100">
+                <a:solidFill>
+                  <a:srgbClr val="5D6878"/>
+                </a:solidFill>
+              </a:defRPr>
+            </a:pPr>
+          </a:p>
+        </c:txPr>
+        <c:crossAx val="-2113994440"/>
+        <c:crosses val="autoZero"/>
+        <c:auto val="1"/>
+        <c:lblAlgn val="ctr"/>
+        <c:lblOffset val="100"/>
+        <c:noMultiLvlLbl val="0"/>
+      </c:catAx>
+      <c:valAx>
+        <c:axId val="-2113994440"/>
+        <c:scaling/>
+        <c:delete/>
+        <c:axPos val="l"/>
+        <c:majorTickMark val="out"/>
+        <c:minorTickMark val="none"/>
+        <c:tickLblPos val="nextTo"/>
+        <c:crossAx val="-2068027336"/>
+        <c:crosses val="autoZero"/>
+      </c:valAx>
+    </c:plotArea>
+    <c:dispBlanksAs val="gap"/>
+  </c:chart>
+  <c:txPr>
+    <a:bodyPr/>
+    <a:lstStyle/>
+    <a:p>
+      <a:pPr>
+        <a:defRPr sz="1800"/>
+      </a:pPr>
+      <a:endParaRPr lang="en-US"/>
+    </a:p>
+  </c:txPr>
+  <c:externalData r:id="rId1">
+    <c:autoUpdate val="0"/>
+  </c:externalData>
+</c:chartSpace>
 </file>
 
 <file path=ppt/notesMasters/notesMaster1.xml><?xml version="1.0" encoding="utf-8"?>
@@ -505,7 +685,7 @@
           <a:lstStyle/>
           <a:p>
             <a:r>
-              <a:t>Speaker note: ARR closed Q3 at $2.6M.</a:t>
+              <a:t>Welcome. Agenda: highlights, metrics, team, financing, customers, then the asks.</a:t>
             </a:r>
           </a:p>
         </p:txBody>
@@ -575,7 +755,7 @@
           <a:lstStyle/>
           <a:p>
             <a:r>
-              <a:t>Speaker note: ARR closed Q3 at $2.6M.</a:t>
+              <a:t>The Globex expansion is the proof point for land-and-expand.</a:t>
             </a:r>
           </a:p>
         </p:txBody>
@@ -645,7 +825,7 @@
           <a:lstStyle/>
           <a:p>
             <a:r>
-              <a:t>Speaker note: ARR closed Q3 at $2.6M.</a:t>
+              <a:t>ARR closed Q3 at $2.6M.</a:t>
             </a:r>
           </a:p>
         </p:txBody>
@@ -715,7 +895,217 @@
           <a:lstStyle/>
           <a:p>
             <a:r>
-              <a:t>Speaker note: ARR closed Q3 at $2.6M.</a:t>
+              <a:t>Hiring plan for Q4 is in the appendix of the pre-read.</a:t>
+            </a:r>
+          </a:p>
+        </p:txBody>
+      </p:sp>
+      <p:sp>
+        <p:nvSpPr>
+          <p:cNvPr id="4" name="Slide Number Placeholder 3"/>
+          <p:cNvSpPr>
+            <a:spLocks noGrp="1"/>
+          </p:cNvSpPr>
+          <p:nvPr>
+            <p:ph type="sldNum" idx="5" sz="quarter"/>
+          </p:nvPr>
+        </p:nvSpPr>
+        <p:spPr/>
+      </p:sp>
+    </p:spTree>
+  </p:cSld>
+  <p:clrMapOvr>
+    <a:masterClrMapping/>
+  </p:clrMapOvr>
+</p:notes>
+</file>
+
+<file path=ppt/notesSlides/notesSlide5.xml><?xml version="1.0" encoding="utf-8"?>
+<p:notes xmlns:a="http://schemas.openxmlformats.org/drawingml/2006/main" xmlns:p="http://schemas.openxmlformats.org/presentationml/2006/main" xmlns:r="http://schemas.openxmlformats.org/officeDocument/2006/relationships">
+  <p:cSld>
+    <p:spTree>
+      <p:nvGrpSpPr>
+        <p:cNvPr id="1" name=""/>
+        <p:cNvGrpSpPr/>
+        <p:nvPr/>
+      </p:nvGrpSpPr>
+      <p:grpSpPr>
+        <a:xfrm>
+          <a:off x="0" y="0"/>
+          <a:ext cx="0" cy="0"/>
+          <a:chOff x="0" y="0"/>
+          <a:chExt cx="0" cy="0"/>
+        </a:xfrm>
+      </p:grpSpPr>
+      <p:sp>
+        <p:nvSpPr>
+          <p:cNvPr id="2" name="Slide Image Placeholder 1"/>
+          <p:cNvSpPr>
+            <a:spLocks noGrp="1"/>
+          </p:cNvSpPr>
+          <p:nvPr>
+            <p:ph type="sldImg" idx="2"/>
+          </p:nvPr>
+        </p:nvSpPr>
+        <p:spPr/>
+      </p:sp>
+      <p:sp>
+        <p:nvSpPr>
+          <p:cNvPr id="3" name="Notes Placeholder 2"/>
+          <p:cNvSpPr>
+            <a:spLocks noGrp="1"/>
+          </p:cNvSpPr>
+          <p:nvPr>
+            <p:ph type="body" idx="3" sz="quarter"/>
+          </p:nvPr>
+        </p:nvSpPr>
+        <p:spPr/>
+        <p:txBody>
+          <a:bodyPr/>
+          <a:lstStyle/>
+          <a:p>
+            <a:r>
+              <a:t>We'd like the board's help with warm intros to the firms on our list.</a:t>
+            </a:r>
+          </a:p>
+        </p:txBody>
+      </p:sp>
+      <p:sp>
+        <p:nvSpPr>
+          <p:cNvPr id="4" name="Slide Number Placeholder 3"/>
+          <p:cNvSpPr>
+            <a:spLocks noGrp="1"/>
+          </p:cNvSpPr>
+          <p:nvPr>
+            <p:ph type="sldNum" idx="5" sz="quarter"/>
+          </p:nvPr>
+        </p:nvSpPr>
+        <p:spPr/>
+      </p:sp>
+    </p:spTree>
+  </p:cSld>
+  <p:clrMapOvr>
+    <a:masterClrMapping/>
+  </p:clrMapOvr>
+</p:notes>
+</file>
+
+<file path=ppt/notesSlides/notesSlide6.xml><?xml version="1.0" encoding="utf-8"?>
+<p:notes xmlns:a="http://schemas.openxmlformats.org/drawingml/2006/main" xmlns:p="http://schemas.openxmlformats.org/presentationml/2006/main" xmlns:r="http://schemas.openxmlformats.org/officeDocument/2006/relationships">
+  <p:cSld>
+    <p:spTree>
+      <p:nvGrpSpPr>
+        <p:cNvPr id="1" name=""/>
+        <p:cNvGrpSpPr/>
+        <p:nvPr/>
+      </p:nvGrpSpPr>
+      <p:grpSpPr>
+        <a:xfrm>
+          <a:off x="0" y="0"/>
+          <a:ext cx="0" cy="0"/>
+          <a:chOff x="0" y="0"/>
+          <a:chExt cx="0" cy="0"/>
+        </a:xfrm>
+      </p:grpSpPr>
+      <p:sp>
+        <p:nvSpPr>
+          <p:cNvPr id="2" name="Slide Image Placeholder 1"/>
+          <p:cNvSpPr>
+            <a:spLocks noGrp="1"/>
+          </p:cNvSpPr>
+          <p:nvPr>
+            <p:ph type="sldImg" idx="2"/>
+          </p:nvPr>
+        </p:nvSpPr>
+        <p:spPr/>
+      </p:sp>
+      <p:sp>
+        <p:nvSpPr>
+          <p:cNvPr id="3" name="Notes Placeholder 2"/>
+          <p:cNvSpPr>
+            <a:spLocks noGrp="1"/>
+          </p:cNvSpPr>
+          <p:nvPr>
+            <p:ph type="body" idx="3" sz="quarter"/>
+          </p:nvPr>
+        </p:nvSpPr>
+        <p:spPr/>
+        <p:txBody>
+          <a:bodyPr/>
+          <a:lstStyle/>
+          <a:p>
+            <a:r>
+              <a:t>Initech's pilot is scoped to one building to start.</a:t>
+            </a:r>
+          </a:p>
+        </p:txBody>
+      </p:sp>
+      <p:sp>
+        <p:nvSpPr>
+          <p:cNvPr id="4" name="Slide Number Placeholder 3"/>
+          <p:cNvSpPr>
+            <a:spLocks noGrp="1"/>
+          </p:cNvSpPr>
+          <p:nvPr>
+            <p:ph type="sldNum" idx="5" sz="quarter"/>
+          </p:nvPr>
+        </p:nvSpPr>
+        <p:spPr/>
+      </p:sp>
+    </p:spTree>
+  </p:cSld>
+  <p:clrMapOvr>
+    <a:masterClrMapping/>
+  </p:clrMapOvr>
+</p:notes>
+</file>
+
+<file path=ppt/notesSlides/notesSlide7.xml><?xml version="1.0" encoding="utf-8"?>
+<p:notes xmlns:a="http://schemas.openxmlformats.org/drawingml/2006/main" xmlns:p="http://schemas.openxmlformats.org/presentationml/2006/main" xmlns:r="http://schemas.openxmlformats.org/officeDocument/2006/relationships">
+  <p:cSld>
+    <p:spTree>
+      <p:nvGrpSpPr>
+        <p:cNvPr id="1" name=""/>
+        <p:cNvGrpSpPr/>
+        <p:nvPr/>
+      </p:nvGrpSpPr>
+      <p:grpSpPr>
+        <a:xfrm>
+          <a:off x="0" y="0"/>
+          <a:ext cx="0" cy="0"/>
+          <a:chOff x="0" y="0"/>
+          <a:chExt cx="0" cy="0"/>
+        </a:xfrm>
+      </p:grpSpPr>
+      <p:sp>
+        <p:nvSpPr>
+          <p:cNvPr id="2" name="Slide Image Placeholder 1"/>
+          <p:cNvSpPr>
+            <a:spLocks noGrp="1"/>
+          </p:cNvSpPr>
+          <p:nvPr>
+            <p:ph type="sldImg" idx="2"/>
+          </p:nvPr>
+        </p:nvSpPr>
+        <p:spPr/>
+      </p:sp>
+      <p:sp>
+        <p:nvSpPr>
+          <p:cNvPr id="3" name="Notes Placeholder 2"/>
+          <p:cNvSpPr>
+            <a:spLocks noGrp="1"/>
+          </p:cNvSpPr>
+          <p:nvPr>
+            <p:ph type="body" idx="3" sz="quarter"/>
+          </p:nvPr>
+        </p:nvSpPr>
+        <p:spPr/>
+        <p:txBody>
+          <a:bodyPr/>
+          <a:lstStyle/>
+          <a:p>
+            <a:r>
+              <a:t>Thank you. Questions?</a:t>
             </a:r>
           </a:p>
         </p:txBody>
@@ -3723,47 +4113,203 @@
       <p:grpSpPr/>
       <p:sp>
         <p:nvSpPr>
-          <p:cNvPr id="2" name="Title 1"/>
-          <p:cNvSpPr>
-            <a:spLocks noGrp="1"/>
-          </p:cNvSpPr>
-          <p:nvPr>
-            <p:ph type="title"/>
-          </p:nvPr>
-        </p:nvSpPr>
-        <p:spPr/>
-        <p:txBody>
-          <a:bodyPr/>
-          <a:lstStyle/>
-          <a:p>
-            <a:r>
-              <a:t>Acme AI - Q3 board update</a:t>
-            </a:r>
-          </a:p>
-        </p:txBody>
-      </p:sp>
-      <p:sp>
-        <p:nvSpPr>
-          <p:cNvPr id="3" name="Content Placeholder 2"/>
-          <p:cNvSpPr>
-            <a:spLocks noGrp="1"/>
-          </p:cNvSpPr>
-          <p:nvPr>
-            <p:ph idx="1"/>
-          </p:nvPr>
-        </p:nvSpPr>
-        <p:spPr/>
-        <p:txBody>
-          <a:bodyPr/>
-          <a:lstStyle/>
-          <a:p>
-            <a:r>
-              <a:t>FICTIONAL company - test data</a:t>
-            </a:r>
-          </a:p>
-          <a:p>
-            <a:r>
-              <a:t>October 2026</a:t>
+          <p:cNvPr id="2" name="Rectangle 1"/>
+          <p:cNvSpPr/>
+          <p:nvPr/>
+        </p:nvSpPr>
+        <p:spPr>
+          <a:xfrm>
+            <a:off x="0" y="0"/>
+            <a:ext cx="12192000" cy="6858000"/>
+          </a:xfrm>
+          <a:prstGeom prst="rect">
+            <a:avLst/>
+          </a:prstGeom>
+          <a:solidFill>
+            <a:srgbClr val="0F1B2D"/>
+          </a:solidFill>
+          <a:ln>
+            <a:noFill/>
+          </a:ln>
+        </p:spPr>
+        <p:style>
+          <a:lnRef idx="1">
+            <a:schemeClr val="accent1"/>
+          </a:lnRef>
+          <a:fillRef idx="3">
+            <a:schemeClr val="accent1"/>
+          </a:fillRef>
+          <a:effectRef idx="2">
+            <a:schemeClr val="accent1"/>
+          </a:effectRef>
+          <a:fontRef idx="minor">
+            <a:schemeClr val="lt1"/>
+          </a:fontRef>
+        </p:style>
+        <p:txBody>
+          <a:bodyPr rtlCol="0" anchor="ctr"/>
+          <a:lstStyle/>
+          <a:p>
+            <a:pPr algn="ctr"/>
+          </a:p>
+        </p:txBody>
+      </p:sp>
+      <p:sp>
+        <p:nvSpPr>
+          <p:cNvPr id="3" name="Oval 2"/>
+          <p:cNvSpPr/>
+          <p:nvPr/>
+        </p:nvSpPr>
+        <p:spPr>
+          <a:xfrm>
+            <a:off x="762000" y="666750"/>
+            <a:ext cx="209550" cy="209550"/>
+          </a:xfrm>
+          <a:prstGeom prst="ellipse">
+            <a:avLst/>
+          </a:prstGeom>
+          <a:solidFill>
+            <a:srgbClr val="E0663A"/>
+          </a:solidFill>
+          <a:ln>
+            <a:noFill/>
+          </a:ln>
+        </p:spPr>
+        <p:style>
+          <a:lnRef idx="1">
+            <a:schemeClr val="accent1"/>
+          </a:lnRef>
+          <a:fillRef idx="3">
+            <a:schemeClr val="accent1"/>
+          </a:fillRef>
+          <a:effectRef idx="2">
+            <a:schemeClr val="accent1"/>
+          </a:effectRef>
+          <a:fontRef idx="minor">
+            <a:schemeClr val="lt1"/>
+          </a:fontRef>
+        </p:style>
+        <p:txBody>
+          <a:bodyPr rtlCol="0" anchor="ctr"/>
+          <a:lstStyle/>
+          <a:p>
+            <a:pPr algn="ctr"/>
+          </a:p>
+        </p:txBody>
+      </p:sp>
+      <p:sp>
+        <p:nvSpPr>
+          <p:cNvPr id="4" name="TextBox 3"/>
+          <p:cNvSpPr txBox="1"/>
+          <p:nvPr/>
+        </p:nvSpPr>
+        <p:spPr>
+          <a:xfrm>
+            <a:off x="1066800" y="609600"/>
+            <a:ext cx="3810000" cy="342900"/>
+          </a:xfrm>
+          <a:prstGeom prst="rect">
+            <a:avLst/>
+          </a:prstGeom>
+          <a:noFill/>
+        </p:spPr>
+        <p:txBody>
+          <a:bodyPr wrap="square">
+            <a:spAutoFit/>
+          </a:bodyPr>
+          <a:lstStyle/>
+          <a:p>
+            <a:pPr>
+              <a:lnSpc>
+                <a:spcPct val="115000"/>
+              </a:lnSpc>
+            </a:pPr>
+            <a:r>
+              <a:rPr sz="1800" b="1">
+                <a:solidFill>
+                  <a:srgbClr val="F4F1EA"/>
+                </a:solidFill>
+                <a:latin typeface="Helvetica Neue"/>
+              </a:rPr>
+              <a:t>Acme AI</a:t>
+            </a:r>
+          </a:p>
+        </p:txBody>
+      </p:sp>
+      <p:sp>
+        <p:nvSpPr>
+          <p:cNvPr id="5" name="TextBox 4"/>
+          <p:cNvSpPr txBox="1"/>
+          <p:nvPr/>
+        </p:nvSpPr>
+        <p:spPr>
+          <a:xfrm>
+            <a:off x="762000" y="2476500"/>
+            <a:ext cx="9525000" cy="1333500"/>
+          </a:xfrm>
+          <a:prstGeom prst="rect">
+            <a:avLst/>
+          </a:prstGeom>
+          <a:noFill/>
+        </p:spPr>
+        <p:txBody>
+          <a:bodyPr wrap="square">
+            <a:spAutoFit/>
+          </a:bodyPr>
+          <a:lstStyle/>
+          <a:p>
+            <a:pPr>
+              <a:lnSpc>
+                <a:spcPct val="115000"/>
+              </a:lnSpc>
+            </a:pPr>
+            <a:r>
+              <a:rPr sz="5400" b="1">
+                <a:solidFill>
+                  <a:srgbClr val="F4F1EA"/>
+                </a:solidFill>
+                <a:latin typeface="Helvetica Neue"/>
+              </a:rPr>
+              <a:t>Acme AI - Q3 2026 board update</a:t>
+            </a:r>
+          </a:p>
+        </p:txBody>
+      </p:sp>
+      <p:sp>
+        <p:nvSpPr>
+          <p:cNvPr id="6" name="TextBox 5"/>
+          <p:cNvSpPr txBox="1"/>
+          <p:nvPr/>
+        </p:nvSpPr>
+        <p:spPr>
+          <a:xfrm>
+            <a:off x="762000" y="3810000"/>
+            <a:ext cx="8572500" cy="381000"/>
+          </a:xfrm>
+          <a:prstGeom prst="rect">
+            <a:avLst/>
+          </a:prstGeom>
+          <a:noFill/>
+        </p:spPr>
+        <p:txBody>
+          <a:bodyPr wrap="square">
+            <a:spAutoFit/>
+          </a:bodyPr>
+          <a:lstStyle/>
+          <a:p>
+            <a:pPr>
+              <a:lnSpc>
+                <a:spcPct val="115000"/>
+              </a:lnSpc>
+            </a:pPr>
+            <a:r>
+              <a:rPr sz="2000" b="0">
+                <a:solidFill>
+                  <a:srgbClr val="AEB6C4"/>
+                </a:solidFill>
+                <a:latin typeface="Helvetica Neue"/>
+              </a:rPr>
+              <a:t>October 2026 · Quarterly board meeting</a:t>
             </a:r>
           </a:p>
         </p:txBody>
@@ -3788,47 +4334,295 @@
       <p:grpSpPr/>
       <p:sp>
         <p:nvSpPr>
-          <p:cNvPr id="2" name="Title 1"/>
-          <p:cNvSpPr>
-            <a:spLocks noGrp="1"/>
-          </p:cNvSpPr>
-          <p:nvPr>
-            <p:ph type="title"/>
-          </p:nvPr>
-        </p:nvSpPr>
-        <p:spPr/>
-        <p:txBody>
-          <a:bodyPr/>
-          <a:lstStyle/>
-          <a:p>
-            <a:r>
-              <a:t>Team</a:t>
-            </a:r>
-          </a:p>
-        </p:txBody>
-      </p:sp>
-      <p:sp>
-        <p:nvSpPr>
-          <p:cNvPr id="3" name="Content Placeholder 2"/>
-          <p:cNvSpPr>
-            <a:spLocks noGrp="1"/>
-          </p:cNvSpPr>
-          <p:nvPr>
-            <p:ph idx="1"/>
-          </p:nvPr>
-        </p:nvSpPr>
-        <p:spPr/>
-        <p:txBody>
-          <a:bodyPr/>
-          <a:lstStyle/>
-          <a:p>
-            <a:r>
-              <a:t>Headcount: 22 full-time (Sep 30)</a:t>
-            </a:r>
-          </a:p>
-          <a:p>
-            <a:r>
-              <a:t>Plus 6 contractors in Lisbon</a:t>
+          <p:cNvPr id="2" name="Rectangle 1"/>
+          <p:cNvSpPr/>
+          <p:nvPr/>
+        </p:nvSpPr>
+        <p:spPr>
+          <a:xfrm>
+            <a:off x="0" y="0"/>
+            <a:ext cx="12192000" cy="6858000"/>
+          </a:xfrm>
+          <a:prstGeom prst="rect">
+            <a:avLst/>
+          </a:prstGeom>
+          <a:solidFill>
+            <a:srgbClr val="FBFAF7"/>
+          </a:solidFill>
+          <a:ln>
+            <a:noFill/>
+          </a:ln>
+        </p:spPr>
+        <p:style>
+          <a:lnRef idx="1">
+            <a:schemeClr val="accent1"/>
+          </a:lnRef>
+          <a:fillRef idx="3">
+            <a:schemeClr val="accent1"/>
+          </a:fillRef>
+          <a:effectRef idx="2">
+            <a:schemeClr val="accent1"/>
+          </a:effectRef>
+          <a:fontRef idx="minor">
+            <a:schemeClr val="lt1"/>
+          </a:fontRef>
+        </p:style>
+        <p:txBody>
+          <a:bodyPr rtlCol="0" anchor="ctr"/>
+          <a:lstStyle/>
+          <a:p>
+            <a:pPr algn="ctr"/>
+          </a:p>
+        </p:txBody>
+      </p:sp>
+      <p:sp>
+        <p:nvSpPr>
+          <p:cNvPr id="3" name="TextBox 2"/>
+          <p:cNvSpPr txBox="1"/>
+          <p:nvPr/>
+        </p:nvSpPr>
+        <p:spPr>
+          <a:xfrm>
+            <a:off x="762000" y="533400"/>
+            <a:ext cx="5715000" cy="228600"/>
+          </a:xfrm>
+          <a:prstGeom prst="rect">
+            <a:avLst/>
+          </a:prstGeom>
+          <a:noFill/>
+        </p:spPr>
+        <p:txBody>
+          <a:bodyPr wrap="square">
+            <a:spAutoFit/>
+          </a:bodyPr>
+          <a:lstStyle/>
+          <a:p>
+            <a:pPr>
+              <a:lnSpc>
+                <a:spcPct val="115000"/>
+              </a:lnSpc>
+            </a:pPr>
+            <a:r>
+              <a:rPr sz="1200" b="1">
+                <a:solidFill>
+                  <a:srgbClr val="E0663A"/>
+                </a:solidFill>
+                <a:latin typeface="Helvetica Neue"/>
+              </a:rPr>
+              <a:t>HIGHLIGHTS</a:t>
+            </a:r>
+          </a:p>
+        </p:txBody>
+      </p:sp>
+      <p:sp>
+        <p:nvSpPr>
+          <p:cNvPr id="4" name="TextBox 3"/>
+          <p:cNvSpPr txBox="1"/>
+          <p:nvPr/>
+        </p:nvSpPr>
+        <p:spPr>
+          <a:xfrm>
+            <a:off x="762000" y="800100"/>
+            <a:ext cx="9525000" cy="666750"/>
+          </a:xfrm>
+          <a:prstGeom prst="rect">
+            <a:avLst/>
+          </a:prstGeom>
+          <a:noFill/>
+        </p:spPr>
+        <p:txBody>
+          <a:bodyPr wrap="square">
+            <a:spAutoFit/>
+          </a:bodyPr>
+          <a:lstStyle/>
+          <a:p>
+            <a:pPr>
+              <a:lnSpc>
+                <a:spcPct val="115000"/>
+              </a:lnSpc>
+            </a:pPr>
+            <a:r>
+              <a:rPr sz="3600" b="1">
+                <a:solidFill>
+                  <a:srgbClr val="0F1B2D"/>
+                </a:solidFill>
+                <a:latin typeface="Helvetica Neue"/>
+              </a:rPr>
+              <a:t>Q3 in one slide</a:t>
+            </a:r>
+          </a:p>
+        </p:txBody>
+      </p:sp>
+      <p:sp>
+        <p:nvSpPr>
+          <p:cNvPr id="5" name="TextBox 4"/>
+          <p:cNvSpPr txBox="1"/>
+          <p:nvPr/>
+        </p:nvSpPr>
+        <p:spPr>
+          <a:xfrm>
+            <a:off x="762000" y="1809750"/>
+            <a:ext cx="9525000" cy="3810000"/>
+          </a:xfrm>
+          <a:prstGeom prst="rect">
+            <a:avLst/>
+          </a:prstGeom>
+          <a:noFill/>
+        </p:spPr>
+        <p:txBody>
+          <a:bodyPr wrap="square">
+            <a:spAutoFit/>
+          </a:bodyPr>
+          <a:lstStyle/>
+          <a:p>
+            <a:pPr>
+              <a:lnSpc>
+                <a:spcPct val="130000"/>
+              </a:lnSpc>
+            </a:pPr>
+            <a:r>
+              <a:rPr sz="2200" b="0">
+                <a:solidFill>
+                  <a:srgbClr val="0F1B2D"/>
+                </a:solidFill>
+                <a:latin typeface="Helvetica Neue"/>
+              </a:rPr>
+              <a:t>•  Globex went live in a second warehouse</a:t>
+            </a:r>
+          </a:p>
+          <a:p>
+            <a:pPr>
+              <a:lnSpc>
+                <a:spcPct val="130000"/>
+              </a:lnSpc>
+              <a:spcBef>
+                <a:spcPts val="1000"/>
+              </a:spcBef>
+            </a:pPr>
+            <a:r>
+              <a:rPr sz="2200" b="0">
+                <a:solidFill>
+                  <a:srgbClr val="0F1B2D"/>
+                </a:solidFill>
+                <a:latin typeface="Helvetica Neue"/>
+              </a:rPr>
+              <a:t>•  Plain-English explanations shipped to every site</a:t>
+            </a:r>
+          </a:p>
+          <a:p>
+            <a:pPr>
+              <a:lnSpc>
+                <a:spcPct val="130000"/>
+              </a:lnSpc>
+              <a:spcBef>
+                <a:spcPts val="1000"/>
+              </a:spcBef>
+            </a:pPr>
+            <a:r>
+              <a:rPr sz="2200" b="0">
+                <a:solidFill>
+                  <a:srgbClr val="0F1B2D"/>
+                </a:solidFill>
+                <a:latin typeface="Helvetica Neue"/>
+              </a:rPr>
+              <a:t>•  Labour planning module in beta with Hooli</a:t>
+            </a:r>
+          </a:p>
+          <a:p>
+            <a:pPr>
+              <a:lnSpc>
+                <a:spcPct val="130000"/>
+              </a:lnSpc>
+              <a:spcBef>
+                <a:spcPts val="1000"/>
+              </a:spcBef>
+            </a:pPr>
+            <a:r>
+              <a:rPr sz="2200" b="0">
+                <a:solidFill>
+                  <a:srgbClr val="0F1B2D"/>
+                </a:solidFill>
+                <a:latin typeface="Helvetica Neue"/>
+              </a:rPr>
+              <a:t>•  Series A preparation underway</a:t>
+            </a:r>
+          </a:p>
+        </p:txBody>
+      </p:sp>
+      <p:sp>
+        <p:nvSpPr>
+          <p:cNvPr id="6" name="TextBox 5"/>
+          <p:cNvSpPr txBox="1"/>
+          <p:nvPr/>
+        </p:nvSpPr>
+        <p:spPr>
+          <a:xfrm>
+            <a:off x="762000" y="6438900"/>
+            <a:ext cx="5715000" cy="228600"/>
+          </a:xfrm>
+          <a:prstGeom prst="rect">
+            <a:avLst/>
+          </a:prstGeom>
+          <a:noFill/>
+        </p:spPr>
+        <p:txBody>
+          <a:bodyPr wrap="square">
+            <a:spAutoFit/>
+          </a:bodyPr>
+          <a:lstStyle/>
+          <a:p>
+            <a:pPr>
+              <a:lnSpc>
+                <a:spcPct val="115000"/>
+              </a:lnSpc>
+            </a:pPr>
+            <a:r>
+              <a:rPr sz="1000" b="0">
+                <a:solidFill>
+                  <a:srgbClr val="9AA1AB"/>
+                </a:solidFill>
+                <a:latin typeface="Helvetica Neue"/>
+              </a:rPr>
+              <a:t>Acme AI · Board update · Confidential</a:t>
+            </a:r>
+          </a:p>
+        </p:txBody>
+      </p:sp>
+      <p:sp>
+        <p:nvSpPr>
+          <p:cNvPr id="7" name="TextBox 6"/>
+          <p:cNvSpPr txBox="1"/>
+          <p:nvPr/>
+        </p:nvSpPr>
+        <p:spPr>
+          <a:xfrm>
+            <a:off x="10477500" y="6438900"/>
+            <a:ext cx="952500" cy="228600"/>
+          </a:xfrm>
+          <a:prstGeom prst="rect">
+            <a:avLst/>
+          </a:prstGeom>
+          <a:noFill/>
+        </p:spPr>
+        <p:txBody>
+          <a:bodyPr wrap="square">
+            <a:spAutoFit/>
+          </a:bodyPr>
+          <a:lstStyle/>
+          <a:p>
+            <a:pPr algn="r">
+              <a:lnSpc>
+                <a:spcPct val="115000"/>
+              </a:lnSpc>
+            </a:pPr>
+            <a:r>
+              <a:rPr sz="1000" b="0">
+                <a:solidFill>
+                  <a:srgbClr val="9AA1AB"/>
+                </a:solidFill>
+                <a:latin typeface="Helvetica Neue"/>
+              </a:rPr>
+              <a:t>2</a:t>
             </a:r>
           </a:p>
         </p:txBody>
@@ -3853,47 +4647,294 @@
       <p:grpSpPr/>
       <p:sp>
         <p:nvSpPr>
-          <p:cNvPr id="2" name="Title 1"/>
-          <p:cNvSpPr>
-            <a:spLocks noGrp="1"/>
-          </p:cNvSpPr>
-          <p:nvPr>
-            <p:ph type="title"/>
-          </p:nvPr>
-        </p:nvSpPr>
-        <p:spPr/>
-        <p:txBody>
-          <a:bodyPr/>
-          <a:lstStyle/>
-          <a:p>
-            <a:r>
-              <a:t>Financing</a:t>
-            </a:r>
-          </a:p>
-        </p:txBody>
-      </p:sp>
-      <p:sp>
-        <p:nvSpPr>
-          <p:cNvPr id="3" name="Content Placeholder 2"/>
-          <p:cNvSpPr>
-            <a:spLocks noGrp="1"/>
-          </p:cNvSpPr>
-          <p:nvPr>
-            <p:ph idx="1"/>
-          </p:nvPr>
-        </p:nvSpPr>
-        <p:spPr/>
-        <p:txBody>
-          <a:bodyPr/>
-          <a:lstStyle/>
-          <a:p>
-            <a:r>
-              <a:t>Raised to date: $12M</a:t>
-            </a:r>
-          </a:p>
-          <a:p>
-            <a:r>
-              <a:t>Series A target: $25M, opening November</a:t>
+          <p:cNvPr id="2" name="Rectangle 1"/>
+          <p:cNvSpPr/>
+          <p:nvPr/>
+        </p:nvSpPr>
+        <p:spPr>
+          <a:xfrm>
+            <a:off x="0" y="0"/>
+            <a:ext cx="12192000" cy="6858000"/>
+          </a:xfrm>
+          <a:prstGeom prst="rect">
+            <a:avLst/>
+          </a:prstGeom>
+          <a:solidFill>
+            <a:srgbClr val="FBFAF7"/>
+          </a:solidFill>
+          <a:ln>
+            <a:noFill/>
+          </a:ln>
+        </p:spPr>
+        <p:style>
+          <a:lnRef idx="1">
+            <a:schemeClr val="accent1"/>
+          </a:lnRef>
+          <a:fillRef idx="3">
+            <a:schemeClr val="accent1"/>
+          </a:fillRef>
+          <a:effectRef idx="2">
+            <a:schemeClr val="accent1"/>
+          </a:effectRef>
+          <a:fontRef idx="minor">
+            <a:schemeClr val="lt1"/>
+          </a:fontRef>
+        </p:style>
+        <p:txBody>
+          <a:bodyPr rtlCol="0" anchor="ctr"/>
+          <a:lstStyle/>
+          <a:p>
+            <a:pPr algn="ctr"/>
+          </a:p>
+        </p:txBody>
+      </p:sp>
+      <p:sp>
+        <p:nvSpPr>
+          <p:cNvPr id="3" name="TextBox 2"/>
+          <p:cNvSpPr txBox="1"/>
+          <p:nvPr/>
+        </p:nvSpPr>
+        <p:spPr>
+          <a:xfrm>
+            <a:off x="762000" y="533400"/>
+            <a:ext cx="5715000" cy="228600"/>
+          </a:xfrm>
+          <a:prstGeom prst="rect">
+            <a:avLst/>
+          </a:prstGeom>
+          <a:noFill/>
+        </p:spPr>
+        <p:txBody>
+          <a:bodyPr wrap="square">
+            <a:spAutoFit/>
+          </a:bodyPr>
+          <a:lstStyle/>
+          <a:p>
+            <a:pPr>
+              <a:lnSpc>
+                <a:spcPct val="115000"/>
+              </a:lnSpc>
+            </a:pPr>
+            <a:r>
+              <a:rPr sz="1200" b="1">
+                <a:solidFill>
+                  <a:srgbClr val="E0663A"/>
+                </a:solidFill>
+                <a:latin typeface="Helvetica Neue"/>
+              </a:rPr>
+              <a:t>METRICS</a:t>
+            </a:r>
+          </a:p>
+        </p:txBody>
+      </p:sp>
+      <p:sp>
+        <p:nvSpPr>
+          <p:cNvPr id="4" name="TextBox 3"/>
+          <p:cNvSpPr txBox="1"/>
+          <p:nvPr/>
+        </p:nvSpPr>
+        <p:spPr>
+          <a:xfrm>
+            <a:off x="762000" y="800100"/>
+            <a:ext cx="9525000" cy="666750"/>
+          </a:xfrm>
+          <a:prstGeom prst="rect">
+            <a:avLst/>
+          </a:prstGeom>
+          <a:noFill/>
+        </p:spPr>
+        <p:txBody>
+          <a:bodyPr wrap="square">
+            <a:spAutoFit/>
+          </a:bodyPr>
+          <a:lstStyle/>
+          <a:p>
+            <a:pPr>
+              <a:lnSpc>
+                <a:spcPct val="115000"/>
+              </a:lnSpc>
+            </a:pPr>
+            <a:r>
+              <a:rPr sz="3600" b="1">
+                <a:solidFill>
+                  <a:srgbClr val="0F1B2D"/>
+                </a:solidFill>
+                <a:latin typeface="Helvetica Neue"/>
+              </a:rPr>
+              <a:t>ARR by month</a:t>
+            </a:r>
+          </a:p>
+        </p:txBody>
+      </p:sp>
+      <p:graphicFrame>
+        <p:nvGraphicFramePr>
+          <p:cNvPr id="5" name="Chart 4"/>
+          <p:cNvGraphicFramePr>
+            <a:graphicFrameLocks noGrp="1"/>
+          </p:cNvGraphicFramePr>
+          <p:nvPr/>
+        </p:nvGraphicFramePr>
+        <p:xfrm>
+          <a:off x="762000" y="1619250"/>
+          <a:ext cx="7239000" cy="4381500"/>
+        </p:xfrm>
+        <a:graphic>
+          <a:graphicData uri="http://schemas.openxmlformats.org/drawingml/2006/chart">
+            <c:chart xmlns:c="http://schemas.openxmlformats.org/drawingml/2006/chart" r:id="rId2"/>
+          </a:graphicData>
+        </a:graphic>
+      </p:graphicFrame>
+      <p:sp>
+        <p:nvSpPr>
+          <p:cNvPr id="6" name="TextBox 5"/>
+          <p:cNvSpPr txBox="1"/>
+          <p:nvPr/>
+        </p:nvSpPr>
+        <p:spPr>
+          <a:xfrm>
+            <a:off x="8382000" y="1809750"/>
+            <a:ext cx="3048000" cy="2857500"/>
+          </a:xfrm>
+          <a:prstGeom prst="rect">
+            <a:avLst/>
+          </a:prstGeom>
+          <a:noFill/>
+        </p:spPr>
+        <p:txBody>
+          <a:bodyPr wrap="square">
+            <a:spAutoFit/>
+          </a:bodyPr>
+          <a:lstStyle/>
+          <a:p>
+            <a:pPr>
+              <a:lnSpc>
+                <a:spcPct val="130000"/>
+              </a:lnSpc>
+            </a:pPr>
+            <a:r>
+              <a:rPr sz="1800" b="0">
+                <a:solidFill>
+                  <a:srgbClr val="0F1B2D"/>
+                </a:solidFill>
+                <a:latin typeface="Helvetica Neue"/>
+              </a:rPr>
+              <a:t>•  Every customer expanded or renewed</a:t>
+            </a:r>
+          </a:p>
+          <a:p>
+            <a:pPr>
+              <a:lnSpc>
+                <a:spcPct val="130000"/>
+              </a:lnSpc>
+              <a:spcBef>
+                <a:spcPts val="1000"/>
+              </a:spcBef>
+            </a:pPr>
+            <a:r>
+              <a:rPr sz="1800" b="0">
+                <a:solidFill>
+                  <a:srgbClr val="0F1B2D"/>
+                </a:solidFill>
+                <a:latin typeface="Helvetica Neue"/>
+              </a:rPr>
+              <a:t>•  No churn this quarter</a:t>
+            </a:r>
+          </a:p>
+          <a:p>
+            <a:pPr>
+              <a:lnSpc>
+                <a:spcPct val="130000"/>
+              </a:lnSpc>
+              <a:spcBef>
+                <a:spcPts val="1000"/>
+              </a:spcBef>
+            </a:pPr>
+            <a:r>
+              <a:rPr sz="1800" b="0">
+                <a:solidFill>
+                  <a:srgbClr val="0F1B2D"/>
+                </a:solidFill>
+                <a:latin typeface="Helvetica Neue"/>
+              </a:rPr>
+              <a:t>•  Pipeline weighted to mid-market 3PLs</a:t>
+            </a:r>
+          </a:p>
+        </p:txBody>
+      </p:sp>
+      <p:sp>
+        <p:nvSpPr>
+          <p:cNvPr id="7" name="TextBox 6"/>
+          <p:cNvSpPr txBox="1"/>
+          <p:nvPr/>
+        </p:nvSpPr>
+        <p:spPr>
+          <a:xfrm>
+            <a:off x="762000" y="6438900"/>
+            <a:ext cx="5715000" cy="228600"/>
+          </a:xfrm>
+          <a:prstGeom prst="rect">
+            <a:avLst/>
+          </a:prstGeom>
+          <a:noFill/>
+        </p:spPr>
+        <p:txBody>
+          <a:bodyPr wrap="square">
+            <a:spAutoFit/>
+          </a:bodyPr>
+          <a:lstStyle/>
+          <a:p>
+            <a:pPr>
+              <a:lnSpc>
+                <a:spcPct val="115000"/>
+              </a:lnSpc>
+            </a:pPr>
+            <a:r>
+              <a:rPr sz="1000" b="0">
+                <a:solidFill>
+                  <a:srgbClr val="9AA1AB"/>
+                </a:solidFill>
+                <a:latin typeface="Helvetica Neue"/>
+              </a:rPr>
+              <a:t>Acme AI · Board update · Confidential</a:t>
+            </a:r>
+          </a:p>
+        </p:txBody>
+      </p:sp>
+      <p:sp>
+        <p:nvSpPr>
+          <p:cNvPr id="8" name="TextBox 7"/>
+          <p:cNvSpPr txBox="1"/>
+          <p:nvPr/>
+        </p:nvSpPr>
+        <p:spPr>
+          <a:xfrm>
+            <a:off x="10477500" y="6438900"/>
+            <a:ext cx="952500" cy="228600"/>
+          </a:xfrm>
+          <a:prstGeom prst="rect">
+            <a:avLst/>
+          </a:prstGeom>
+          <a:noFill/>
+        </p:spPr>
+        <p:txBody>
+          <a:bodyPr wrap="square">
+            <a:spAutoFit/>
+          </a:bodyPr>
+          <a:lstStyle/>
+          <a:p>
+            <a:pPr algn="r">
+              <a:lnSpc>
+                <a:spcPct val="115000"/>
+              </a:lnSpc>
+            </a:pPr>
+            <a:r>
+              <a:rPr sz="1000" b="0">
+                <a:solidFill>
+                  <a:srgbClr val="9AA1AB"/>
+                </a:solidFill>
+                <a:latin typeface="Helvetica Neue"/>
+              </a:rPr>
+              <a:t>3</a:t>
             </a:r>
           </a:p>
         </p:txBody>
@@ -3918,20 +4959,958 @@
       <p:grpSpPr/>
       <p:sp>
         <p:nvSpPr>
-          <p:cNvPr id="2" name="Title 1"/>
-          <p:cNvSpPr>
-            <a:spLocks noGrp="1"/>
-          </p:cNvSpPr>
-          <p:nvPr>
-            <p:ph type="title"/>
-          </p:nvPr>
-        </p:nvSpPr>
-        <p:spPr/>
-        <p:txBody>
-          <a:bodyPr/>
-          <a:lstStyle/>
-          <a:p>
-            <a:r>
+          <p:cNvPr id="2" name="Rectangle 1"/>
+          <p:cNvSpPr/>
+          <p:nvPr/>
+        </p:nvSpPr>
+        <p:spPr>
+          <a:xfrm>
+            <a:off x="0" y="0"/>
+            <a:ext cx="12192000" cy="6858000"/>
+          </a:xfrm>
+          <a:prstGeom prst="rect">
+            <a:avLst/>
+          </a:prstGeom>
+          <a:solidFill>
+            <a:srgbClr val="FBFAF7"/>
+          </a:solidFill>
+          <a:ln>
+            <a:noFill/>
+          </a:ln>
+        </p:spPr>
+        <p:style>
+          <a:lnRef idx="1">
+            <a:schemeClr val="accent1"/>
+          </a:lnRef>
+          <a:fillRef idx="3">
+            <a:schemeClr val="accent1"/>
+          </a:fillRef>
+          <a:effectRef idx="2">
+            <a:schemeClr val="accent1"/>
+          </a:effectRef>
+          <a:fontRef idx="minor">
+            <a:schemeClr val="lt1"/>
+          </a:fontRef>
+        </p:style>
+        <p:txBody>
+          <a:bodyPr rtlCol="0" anchor="ctr"/>
+          <a:lstStyle/>
+          <a:p>
+            <a:pPr algn="ctr"/>
+          </a:p>
+        </p:txBody>
+      </p:sp>
+      <p:sp>
+        <p:nvSpPr>
+          <p:cNvPr id="3" name="TextBox 2"/>
+          <p:cNvSpPr txBox="1"/>
+          <p:nvPr/>
+        </p:nvSpPr>
+        <p:spPr>
+          <a:xfrm>
+            <a:off x="762000" y="533400"/>
+            <a:ext cx="5715000" cy="228600"/>
+          </a:xfrm>
+          <a:prstGeom prst="rect">
+            <a:avLst/>
+          </a:prstGeom>
+          <a:noFill/>
+        </p:spPr>
+        <p:txBody>
+          <a:bodyPr wrap="square">
+            <a:spAutoFit/>
+          </a:bodyPr>
+          <a:lstStyle/>
+          <a:p>
+            <a:pPr>
+              <a:lnSpc>
+                <a:spcPct val="115000"/>
+              </a:lnSpc>
+            </a:pPr>
+            <a:r>
+              <a:rPr sz="1200" b="1">
+                <a:solidFill>
+                  <a:srgbClr val="E0663A"/>
+                </a:solidFill>
+                <a:latin typeface="Helvetica Neue"/>
+              </a:rPr>
+              <a:t>TEAM</a:t>
+            </a:r>
+          </a:p>
+        </p:txBody>
+      </p:sp>
+      <p:sp>
+        <p:nvSpPr>
+          <p:cNvPr id="4" name="TextBox 3"/>
+          <p:cNvSpPr txBox="1"/>
+          <p:nvPr/>
+        </p:nvSpPr>
+        <p:spPr>
+          <a:xfrm>
+            <a:off x="762000" y="800100"/>
+            <a:ext cx="9525000" cy="666750"/>
+          </a:xfrm>
+          <a:prstGeom prst="rect">
+            <a:avLst/>
+          </a:prstGeom>
+          <a:noFill/>
+        </p:spPr>
+        <p:txBody>
+          <a:bodyPr wrap="square">
+            <a:spAutoFit/>
+          </a:bodyPr>
+          <a:lstStyle/>
+          <a:p>
+            <a:pPr>
+              <a:lnSpc>
+                <a:spcPct val="115000"/>
+              </a:lnSpc>
+            </a:pPr>
+            <a:r>
+              <a:rPr sz="3600" b="1">
+                <a:solidFill>
+                  <a:srgbClr val="0F1B2D"/>
+                </a:solidFill>
+                <a:latin typeface="Helvetica Neue"/>
+              </a:rPr>
+              <a:t>Team</a:t>
+            </a:r>
+          </a:p>
+        </p:txBody>
+      </p:sp>
+      <p:sp>
+        <p:nvSpPr>
+          <p:cNvPr id="5" name="TextBox 4"/>
+          <p:cNvSpPr txBox="1"/>
+          <p:nvPr/>
+        </p:nvSpPr>
+        <p:spPr>
+          <a:xfrm>
+            <a:off x="762000" y="1809750"/>
+            <a:ext cx="5905500" cy="571500"/>
+          </a:xfrm>
+          <a:prstGeom prst="rect">
+            <a:avLst/>
+          </a:prstGeom>
+          <a:noFill/>
+        </p:spPr>
+        <p:txBody>
+          <a:bodyPr wrap="square">
+            <a:spAutoFit/>
+          </a:bodyPr>
+          <a:lstStyle/>
+          <a:p>
+            <a:pPr>
+              <a:lnSpc>
+                <a:spcPct val="115000"/>
+              </a:lnSpc>
+            </a:pPr>
+            <a:r>
+              <a:rPr sz="3000" b="1">
+                <a:solidFill>
+                  <a:srgbClr val="0F1B2D"/>
+                </a:solidFill>
+                <a:latin typeface="Helvetica Neue"/>
+              </a:rPr>
+              <a:t>Headcount: 22 full-time (Sep 30)</a:t>
+            </a:r>
+          </a:p>
+        </p:txBody>
+      </p:sp>
+      <p:sp>
+        <p:nvSpPr>
+          <p:cNvPr id="6" name="TextBox 5"/>
+          <p:cNvSpPr txBox="1"/>
+          <p:nvPr/>
+        </p:nvSpPr>
+        <p:spPr>
+          <a:xfrm>
+            <a:off x="762000" y="2381250"/>
+            <a:ext cx="5905500" cy="381000"/>
+          </a:xfrm>
+          <a:prstGeom prst="rect">
+            <a:avLst/>
+          </a:prstGeom>
+          <a:noFill/>
+        </p:spPr>
+        <p:txBody>
+          <a:bodyPr wrap="square">
+            <a:spAutoFit/>
+          </a:bodyPr>
+          <a:lstStyle/>
+          <a:p>
+            <a:pPr>
+              <a:lnSpc>
+                <a:spcPct val="115000"/>
+              </a:lnSpc>
+            </a:pPr>
+            <a:r>
+              <a:rPr sz="2200" b="0">
+                <a:solidFill>
+                  <a:srgbClr val="5D6878"/>
+                </a:solidFill>
+                <a:latin typeface="Helvetica Neue"/>
+              </a:rPr>
+              <a:t>Plus 6 contractors in Lisbon</a:t>
+            </a:r>
+          </a:p>
+        </p:txBody>
+      </p:sp>
+      <p:sp>
+        <p:nvSpPr>
+          <p:cNvPr id="7" name="Rounded Rectangle 6"/>
+          <p:cNvSpPr/>
+          <p:nvPr/>
+        </p:nvSpPr>
+        <p:spPr>
+          <a:xfrm>
+            <a:off x="7239000" y="1714500"/>
+            <a:ext cx="4191000" cy="2857500"/>
+          </a:xfrm>
+          <a:prstGeom prst="roundRect">
+            <a:avLst>
+              <a:gd name="adj" fmla="val 6000"/>
+            </a:avLst>
+          </a:prstGeom>
+          <a:solidFill>
+            <a:srgbClr val="FFFFFF"/>
+          </a:solidFill>
+          <a:ln>
+            <a:solidFill>
+              <a:srgbClr val="E6E2D9"/>
+            </a:solidFill>
+          </a:ln>
+        </p:spPr>
+        <p:style>
+          <a:lnRef idx="1">
+            <a:schemeClr val="accent1"/>
+          </a:lnRef>
+          <a:fillRef idx="3">
+            <a:schemeClr val="accent1"/>
+          </a:fillRef>
+          <a:effectRef idx="2">
+            <a:schemeClr val="accent1"/>
+          </a:effectRef>
+          <a:fontRef idx="minor">
+            <a:schemeClr val="lt1"/>
+          </a:fontRef>
+        </p:style>
+        <p:txBody>
+          <a:bodyPr rtlCol="0" anchor="ctr"/>
+          <a:lstStyle/>
+          <a:p>
+            <a:pPr algn="ctr"/>
+          </a:p>
+        </p:txBody>
+      </p:sp>
+      <p:sp>
+        <p:nvSpPr>
+          <p:cNvPr id="8" name="TextBox 7"/>
+          <p:cNvSpPr txBox="1"/>
+          <p:nvPr/>
+        </p:nvSpPr>
+        <p:spPr>
+          <a:xfrm>
+            <a:off x="7524750" y="1952625"/>
+            <a:ext cx="3714750" cy="2476500"/>
+          </a:xfrm>
+          <a:prstGeom prst="rect">
+            <a:avLst/>
+          </a:prstGeom>
+          <a:noFill/>
+        </p:spPr>
+        <p:txBody>
+          <a:bodyPr wrap="square">
+            <a:spAutoFit/>
+          </a:bodyPr>
+          <a:lstStyle/>
+          <a:p>
+            <a:pPr>
+              <a:lnSpc>
+                <a:spcPct val="130000"/>
+              </a:lnSpc>
+            </a:pPr>
+            <a:r>
+              <a:rPr sz="1700" b="0">
+                <a:solidFill>
+                  <a:srgbClr val="0F1B2D"/>
+                </a:solidFill>
+                <a:latin typeface="Helvetica Neue"/>
+              </a:rPr>
+              <a:t>•  Hired: two engineers</a:t>
+            </a:r>
+          </a:p>
+          <a:p>
+            <a:pPr>
+              <a:lnSpc>
+                <a:spcPct val="130000"/>
+              </a:lnSpc>
+              <a:spcBef>
+                <a:spcPts val="1000"/>
+              </a:spcBef>
+            </a:pPr>
+            <a:r>
+              <a:rPr sz="1700" b="0">
+                <a:solidFill>
+                  <a:srgbClr val="0F1B2D"/>
+                </a:solidFill>
+                <a:latin typeface="Helvetica Neue"/>
+              </a:rPr>
+              <a:t>•  Open: Staff ML engineer</a:t>
+            </a:r>
+          </a:p>
+          <a:p>
+            <a:pPr>
+              <a:lnSpc>
+                <a:spcPct val="130000"/>
+              </a:lnSpc>
+              <a:spcBef>
+                <a:spcPts val="1000"/>
+              </a:spcBef>
+            </a:pPr>
+            <a:r>
+              <a:rPr sz="1700" b="0">
+                <a:solidFill>
+                  <a:srgbClr val="0F1B2D"/>
+                </a:solidFill>
+                <a:latin typeface="Helvetica Neue"/>
+              </a:rPr>
+              <a:t>•  Open: Head of Customer Success, Europe</a:t>
+            </a:r>
+          </a:p>
+        </p:txBody>
+      </p:sp>
+      <p:sp>
+        <p:nvSpPr>
+          <p:cNvPr id="9" name="TextBox 8"/>
+          <p:cNvSpPr txBox="1"/>
+          <p:nvPr/>
+        </p:nvSpPr>
+        <p:spPr>
+          <a:xfrm>
+            <a:off x="762000" y="6438900"/>
+            <a:ext cx="5715000" cy="228600"/>
+          </a:xfrm>
+          <a:prstGeom prst="rect">
+            <a:avLst/>
+          </a:prstGeom>
+          <a:noFill/>
+        </p:spPr>
+        <p:txBody>
+          <a:bodyPr wrap="square">
+            <a:spAutoFit/>
+          </a:bodyPr>
+          <a:lstStyle/>
+          <a:p>
+            <a:pPr>
+              <a:lnSpc>
+                <a:spcPct val="115000"/>
+              </a:lnSpc>
+            </a:pPr>
+            <a:r>
+              <a:rPr sz="1000" b="0">
+                <a:solidFill>
+                  <a:srgbClr val="9AA1AB"/>
+                </a:solidFill>
+                <a:latin typeface="Helvetica Neue"/>
+              </a:rPr>
+              <a:t>Acme AI · Board update · Confidential</a:t>
+            </a:r>
+          </a:p>
+        </p:txBody>
+      </p:sp>
+      <p:sp>
+        <p:nvSpPr>
+          <p:cNvPr id="10" name="TextBox 9"/>
+          <p:cNvSpPr txBox="1"/>
+          <p:nvPr/>
+        </p:nvSpPr>
+        <p:spPr>
+          <a:xfrm>
+            <a:off x="10477500" y="6438900"/>
+            <a:ext cx="952500" cy="228600"/>
+          </a:xfrm>
+          <a:prstGeom prst="rect">
+            <a:avLst/>
+          </a:prstGeom>
+          <a:noFill/>
+        </p:spPr>
+        <p:txBody>
+          <a:bodyPr wrap="square">
+            <a:spAutoFit/>
+          </a:bodyPr>
+          <a:lstStyle/>
+          <a:p>
+            <a:pPr algn="r">
+              <a:lnSpc>
+                <a:spcPct val="115000"/>
+              </a:lnSpc>
+            </a:pPr>
+            <a:r>
+              <a:rPr sz="1000" b="0">
+                <a:solidFill>
+                  <a:srgbClr val="9AA1AB"/>
+                </a:solidFill>
+                <a:latin typeface="Helvetica Neue"/>
+              </a:rPr>
+              <a:t>4</a:t>
+            </a:r>
+          </a:p>
+        </p:txBody>
+      </p:sp>
+    </p:spTree>
+  </p:cSld>
+  <p:clrMapOvr>
+    <a:masterClrMapping/>
+  </p:clrMapOvr>
+</p:sld>
+</file>
+
+<file path=ppt/slides/slide5.xml><?xml version="1.0" encoding="utf-8"?>
+<p:sld xmlns:a="http://schemas.openxmlformats.org/drawingml/2006/main" xmlns:p="http://schemas.openxmlformats.org/presentationml/2006/main" xmlns:r="http://schemas.openxmlformats.org/officeDocument/2006/relationships">
+  <p:cSld>
+    <p:spTree>
+      <p:nvGrpSpPr>
+        <p:cNvPr id="1" name=""/>
+        <p:cNvGrpSpPr/>
+        <p:nvPr/>
+      </p:nvGrpSpPr>
+      <p:grpSpPr/>
+      <p:sp>
+        <p:nvSpPr>
+          <p:cNvPr id="2" name="Rectangle 1"/>
+          <p:cNvSpPr/>
+          <p:nvPr/>
+        </p:nvSpPr>
+        <p:spPr>
+          <a:xfrm>
+            <a:off x="0" y="0"/>
+            <a:ext cx="12192000" cy="6858000"/>
+          </a:xfrm>
+          <a:prstGeom prst="rect">
+            <a:avLst/>
+          </a:prstGeom>
+          <a:solidFill>
+            <a:srgbClr val="FBFAF7"/>
+          </a:solidFill>
+          <a:ln>
+            <a:noFill/>
+          </a:ln>
+        </p:spPr>
+        <p:style>
+          <a:lnRef idx="1">
+            <a:schemeClr val="accent1"/>
+          </a:lnRef>
+          <a:fillRef idx="3">
+            <a:schemeClr val="accent1"/>
+          </a:fillRef>
+          <a:effectRef idx="2">
+            <a:schemeClr val="accent1"/>
+          </a:effectRef>
+          <a:fontRef idx="minor">
+            <a:schemeClr val="lt1"/>
+          </a:fontRef>
+        </p:style>
+        <p:txBody>
+          <a:bodyPr rtlCol="0" anchor="ctr"/>
+          <a:lstStyle/>
+          <a:p>
+            <a:pPr algn="ctr"/>
+          </a:p>
+        </p:txBody>
+      </p:sp>
+      <p:sp>
+        <p:nvSpPr>
+          <p:cNvPr id="3" name="TextBox 2"/>
+          <p:cNvSpPr txBox="1"/>
+          <p:nvPr/>
+        </p:nvSpPr>
+        <p:spPr>
+          <a:xfrm>
+            <a:off x="762000" y="533400"/>
+            <a:ext cx="5715000" cy="228600"/>
+          </a:xfrm>
+          <a:prstGeom prst="rect">
+            <a:avLst/>
+          </a:prstGeom>
+          <a:noFill/>
+        </p:spPr>
+        <p:txBody>
+          <a:bodyPr wrap="square">
+            <a:spAutoFit/>
+          </a:bodyPr>
+          <a:lstStyle/>
+          <a:p>
+            <a:pPr>
+              <a:lnSpc>
+                <a:spcPct val="115000"/>
+              </a:lnSpc>
+            </a:pPr>
+            <a:r>
+              <a:rPr sz="1200" b="1">
+                <a:solidFill>
+                  <a:srgbClr val="E0663A"/>
+                </a:solidFill>
+                <a:latin typeface="Helvetica Neue"/>
+              </a:rPr>
+              <a:t>FINANCING</a:t>
+            </a:r>
+          </a:p>
+        </p:txBody>
+      </p:sp>
+      <p:sp>
+        <p:nvSpPr>
+          <p:cNvPr id="4" name="TextBox 3"/>
+          <p:cNvSpPr txBox="1"/>
+          <p:nvPr/>
+        </p:nvSpPr>
+        <p:spPr>
+          <a:xfrm>
+            <a:off x="762000" y="800100"/>
+            <a:ext cx="9525000" cy="666750"/>
+          </a:xfrm>
+          <a:prstGeom prst="rect">
+            <a:avLst/>
+          </a:prstGeom>
+          <a:noFill/>
+        </p:spPr>
+        <p:txBody>
+          <a:bodyPr wrap="square">
+            <a:spAutoFit/>
+          </a:bodyPr>
+          <a:lstStyle/>
+          <a:p>
+            <a:pPr>
+              <a:lnSpc>
+                <a:spcPct val="115000"/>
+              </a:lnSpc>
+            </a:pPr>
+            <a:r>
+              <a:rPr sz="3600" b="1">
+                <a:solidFill>
+                  <a:srgbClr val="0F1B2D"/>
+                </a:solidFill>
+                <a:latin typeface="Helvetica Neue"/>
+              </a:rPr>
+              <a:t>Financing</a:t>
+            </a:r>
+          </a:p>
+        </p:txBody>
+      </p:sp>
+      <p:sp>
+        <p:nvSpPr>
+          <p:cNvPr id="5" name="TextBox 4"/>
+          <p:cNvSpPr txBox="1"/>
+          <p:nvPr/>
+        </p:nvSpPr>
+        <p:spPr>
+          <a:xfrm>
+            <a:off x="762000" y="1809750"/>
+            <a:ext cx="5905500" cy="571500"/>
+          </a:xfrm>
+          <a:prstGeom prst="rect">
+            <a:avLst/>
+          </a:prstGeom>
+          <a:noFill/>
+        </p:spPr>
+        <p:txBody>
+          <a:bodyPr wrap="square">
+            <a:spAutoFit/>
+          </a:bodyPr>
+          <a:lstStyle/>
+          <a:p>
+            <a:pPr>
+              <a:lnSpc>
+                <a:spcPct val="115000"/>
+              </a:lnSpc>
+            </a:pPr>
+            <a:r>
+              <a:rPr sz="3000" b="1">
+                <a:solidFill>
+                  <a:srgbClr val="0F1B2D"/>
+                </a:solidFill>
+                <a:latin typeface="Helvetica Neue"/>
+              </a:rPr>
+              <a:t>Raised to date: $12M</a:t>
+            </a:r>
+          </a:p>
+        </p:txBody>
+      </p:sp>
+      <p:sp>
+        <p:nvSpPr>
+          <p:cNvPr id="6" name="TextBox 5"/>
+          <p:cNvSpPr txBox="1"/>
+          <p:nvPr/>
+        </p:nvSpPr>
+        <p:spPr>
+          <a:xfrm>
+            <a:off x="762000" y="2381250"/>
+            <a:ext cx="5905500" cy="381000"/>
+          </a:xfrm>
+          <a:prstGeom prst="rect">
+            <a:avLst/>
+          </a:prstGeom>
+          <a:noFill/>
+        </p:spPr>
+        <p:txBody>
+          <a:bodyPr wrap="square">
+            <a:spAutoFit/>
+          </a:bodyPr>
+          <a:lstStyle/>
+          <a:p>
+            <a:pPr>
+              <a:lnSpc>
+                <a:spcPct val="115000"/>
+              </a:lnSpc>
+            </a:pPr>
+            <a:r>
+              <a:rPr sz="2200" b="0">
+                <a:solidFill>
+                  <a:srgbClr val="5D6878"/>
+                </a:solidFill>
+                <a:latin typeface="Helvetica Neue"/>
+              </a:rPr>
+              <a:t>Series A target: $25M, opening November</a:t>
+            </a:r>
+          </a:p>
+        </p:txBody>
+      </p:sp>
+      <p:sp>
+        <p:nvSpPr>
+          <p:cNvPr id="7" name="Rounded Rectangle 6"/>
+          <p:cNvSpPr/>
+          <p:nvPr/>
+        </p:nvSpPr>
+        <p:spPr>
+          <a:xfrm>
+            <a:off x="7239000" y="1714500"/>
+            <a:ext cx="4191000" cy="2857500"/>
+          </a:xfrm>
+          <a:prstGeom prst="roundRect">
+            <a:avLst>
+              <a:gd name="adj" fmla="val 6000"/>
+            </a:avLst>
+          </a:prstGeom>
+          <a:solidFill>
+            <a:srgbClr val="FFFFFF"/>
+          </a:solidFill>
+          <a:ln>
+            <a:solidFill>
+              <a:srgbClr val="E6E2D9"/>
+            </a:solidFill>
+          </a:ln>
+        </p:spPr>
+        <p:style>
+          <a:lnRef idx="1">
+            <a:schemeClr val="accent1"/>
+          </a:lnRef>
+          <a:fillRef idx="3">
+            <a:schemeClr val="accent1"/>
+          </a:fillRef>
+          <a:effectRef idx="2">
+            <a:schemeClr val="accent1"/>
+          </a:effectRef>
+          <a:fontRef idx="minor">
+            <a:schemeClr val="lt1"/>
+          </a:fontRef>
+        </p:style>
+        <p:txBody>
+          <a:bodyPr rtlCol="0" anchor="ctr"/>
+          <a:lstStyle/>
+          <a:p>
+            <a:pPr algn="ctr"/>
+          </a:p>
+        </p:txBody>
+      </p:sp>
+      <p:sp>
+        <p:nvSpPr>
+          <p:cNvPr id="8" name="TextBox 7"/>
+          <p:cNvSpPr txBox="1"/>
+          <p:nvPr/>
+        </p:nvSpPr>
+        <p:spPr>
+          <a:xfrm>
+            <a:off x="7524750" y="1952625"/>
+            <a:ext cx="3714750" cy="2476500"/>
+          </a:xfrm>
+          <a:prstGeom prst="rect">
+            <a:avLst/>
+          </a:prstGeom>
+          <a:noFill/>
+        </p:spPr>
+        <p:txBody>
+          <a:bodyPr wrap="square">
+            <a:spAutoFit/>
+          </a:bodyPr>
+          <a:lstStyle/>
+          <a:p>
+            <a:pPr>
+              <a:lnSpc>
+                <a:spcPct val="130000"/>
+              </a:lnSpc>
+            </a:pPr>
+            <a:r>
+              <a:rPr sz="1700" b="0">
+                <a:solidFill>
+                  <a:srgbClr val="0F1B2D"/>
+                </a:solidFill>
+                <a:latin typeface="Helvetica Neue"/>
+              </a:rPr>
+              <a:t>•  October: data room and model ready</a:t>
+            </a:r>
+          </a:p>
+          <a:p>
+            <a:pPr>
+              <a:lnSpc>
+                <a:spcPct val="130000"/>
+              </a:lnSpc>
+              <a:spcBef>
+                <a:spcPts val="1000"/>
+              </a:spcBef>
+            </a:pPr>
+            <a:r>
+              <a:rPr sz="1700" b="0">
+                <a:solidFill>
+                  <a:srgbClr val="0F1B2D"/>
+                </a:solidFill>
+                <a:latin typeface="Helvetica Neue"/>
+              </a:rPr>
+              <a:t>•  November: first meetings</a:t>
+            </a:r>
+          </a:p>
+          <a:p>
+            <a:pPr>
+              <a:lnSpc>
+                <a:spcPct val="130000"/>
+              </a:lnSpc>
+              <a:spcBef>
+                <a:spcPts val="1000"/>
+              </a:spcBef>
+            </a:pPr>
+            <a:r>
+              <a:rPr sz="1700" b="0">
+                <a:solidFill>
+                  <a:srgbClr val="0F1B2D"/>
+                </a:solidFill>
+                <a:latin typeface="Helvetica Neue"/>
+              </a:rPr>
+              <a:t>•  December: target term sheet</a:t>
+            </a:r>
+          </a:p>
+        </p:txBody>
+      </p:sp>
+      <p:sp>
+        <p:nvSpPr>
+          <p:cNvPr id="9" name="TextBox 8"/>
+          <p:cNvSpPr txBox="1"/>
+          <p:nvPr/>
+        </p:nvSpPr>
+        <p:spPr>
+          <a:xfrm>
+            <a:off x="762000" y="6438900"/>
+            <a:ext cx="5715000" cy="228600"/>
+          </a:xfrm>
+          <a:prstGeom prst="rect">
+            <a:avLst/>
+          </a:prstGeom>
+          <a:noFill/>
+        </p:spPr>
+        <p:txBody>
+          <a:bodyPr wrap="square">
+            <a:spAutoFit/>
+          </a:bodyPr>
+          <a:lstStyle/>
+          <a:p>
+            <a:pPr>
+              <a:lnSpc>
+                <a:spcPct val="115000"/>
+              </a:lnSpc>
+            </a:pPr>
+            <a:r>
+              <a:rPr sz="1000" b="0">
+                <a:solidFill>
+                  <a:srgbClr val="9AA1AB"/>
+                </a:solidFill>
+                <a:latin typeface="Helvetica Neue"/>
+              </a:rPr>
+              <a:t>Acme AI · Board update · Confidential</a:t>
+            </a:r>
+          </a:p>
+        </p:txBody>
+      </p:sp>
+      <p:sp>
+        <p:nvSpPr>
+          <p:cNvPr id="10" name="TextBox 9"/>
+          <p:cNvSpPr txBox="1"/>
+          <p:nvPr/>
+        </p:nvSpPr>
+        <p:spPr>
+          <a:xfrm>
+            <a:off x="10477500" y="6438900"/>
+            <a:ext cx="952500" cy="228600"/>
+          </a:xfrm>
+          <a:prstGeom prst="rect">
+            <a:avLst/>
+          </a:prstGeom>
+          <a:noFill/>
+        </p:spPr>
+        <p:txBody>
+          <a:bodyPr wrap="square">
+            <a:spAutoFit/>
+          </a:bodyPr>
+          <a:lstStyle/>
+          <a:p>
+            <a:pPr algn="r">
+              <a:lnSpc>
+                <a:spcPct val="115000"/>
+              </a:lnSpc>
+            </a:pPr>
+            <a:r>
+              <a:rPr sz="1000" b="0">
+                <a:solidFill>
+                  <a:srgbClr val="9AA1AB"/>
+                </a:solidFill>
+                <a:latin typeface="Helvetica Neue"/>
+              </a:rPr>
+              <a:t>5</a:t>
+            </a:r>
+          </a:p>
+        </p:txBody>
+      </p:sp>
+    </p:spTree>
+  </p:cSld>
+  <p:clrMapOvr>
+    <a:masterClrMapping/>
+  </p:clrMapOvr>
+</p:sld>
+</file>
+
+<file path=ppt/slides/slide6.xml><?xml version="1.0" encoding="utf-8"?>
+<p:sld xmlns:a="http://schemas.openxmlformats.org/drawingml/2006/main" xmlns:p="http://schemas.openxmlformats.org/presentationml/2006/main" xmlns:r="http://schemas.openxmlformats.org/officeDocument/2006/relationships">
+  <p:cSld>
+    <p:spTree>
+      <p:nvGrpSpPr>
+        <p:cNvPr id="1" name=""/>
+        <p:cNvGrpSpPr/>
+        <p:nvPr/>
+      </p:nvGrpSpPr>
+      <p:grpSpPr/>
+      <p:sp>
+        <p:nvSpPr>
+          <p:cNvPr id="2" name="Rectangle 1"/>
+          <p:cNvSpPr/>
+          <p:nvPr/>
+        </p:nvSpPr>
+        <p:spPr>
+          <a:xfrm>
+            <a:off x="0" y="0"/>
+            <a:ext cx="12192000" cy="6858000"/>
+          </a:xfrm>
+          <a:prstGeom prst="rect">
+            <a:avLst/>
+          </a:prstGeom>
+          <a:solidFill>
+            <a:srgbClr val="FBFAF7"/>
+          </a:solidFill>
+          <a:ln>
+            <a:noFill/>
+          </a:ln>
+        </p:spPr>
+        <p:style>
+          <a:lnRef idx="1">
+            <a:schemeClr val="accent1"/>
+          </a:lnRef>
+          <a:fillRef idx="3">
+            <a:schemeClr val="accent1"/>
+          </a:fillRef>
+          <a:effectRef idx="2">
+            <a:schemeClr val="accent1"/>
+          </a:effectRef>
+          <a:fontRef idx="minor">
+            <a:schemeClr val="lt1"/>
+          </a:fontRef>
+        </p:style>
+        <p:txBody>
+          <a:bodyPr rtlCol="0" anchor="ctr"/>
+          <a:lstStyle/>
+          <a:p>
+            <a:pPr algn="ctr"/>
+          </a:p>
+        </p:txBody>
+      </p:sp>
+      <p:sp>
+        <p:nvSpPr>
+          <p:cNvPr id="3" name="TextBox 2"/>
+          <p:cNvSpPr txBox="1"/>
+          <p:nvPr/>
+        </p:nvSpPr>
+        <p:spPr>
+          <a:xfrm>
+            <a:off x="762000" y="533400"/>
+            <a:ext cx="5715000" cy="228600"/>
+          </a:xfrm>
+          <a:prstGeom prst="rect">
+            <a:avLst/>
+          </a:prstGeom>
+          <a:noFill/>
+        </p:spPr>
+        <p:txBody>
+          <a:bodyPr wrap="square">
+            <a:spAutoFit/>
+          </a:bodyPr>
+          <a:lstStyle/>
+          <a:p>
+            <a:pPr>
+              <a:lnSpc>
+                <a:spcPct val="115000"/>
+              </a:lnSpc>
+            </a:pPr>
+            <a:r>
+              <a:rPr sz="1200" b="1">
+                <a:solidFill>
+                  <a:srgbClr val="E0663A"/>
+                </a:solidFill>
+                <a:latin typeface="Helvetica Neue"/>
+              </a:rPr>
+              <a:t>CUSTOMERS</a:t>
+            </a:r>
+          </a:p>
+        </p:txBody>
+      </p:sp>
+      <p:sp>
+        <p:nvSpPr>
+          <p:cNvPr id="4" name="TextBox 3"/>
+          <p:cNvSpPr txBox="1"/>
+          <p:nvPr/>
+        </p:nvSpPr>
+        <p:spPr>
+          <a:xfrm>
+            <a:off x="762000" y="800100"/>
+            <a:ext cx="9525000" cy="666750"/>
+          </a:xfrm>
+          <a:prstGeom prst="rect">
+            <a:avLst/>
+          </a:prstGeom>
+          <a:noFill/>
+        </p:spPr>
+        <p:txBody>
+          <a:bodyPr wrap="square">
+            <a:spAutoFit/>
+          </a:bodyPr>
+          <a:lstStyle/>
+          <a:p>
+            <a:pPr>
+              <a:lnSpc>
+                <a:spcPct val="115000"/>
+              </a:lnSpc>
+            </a:pPr>
+            <a:r>
+              <a:rPr sz="3600" b="1">
+                <a:solidFill>
+                  <a:srgbClr val="0F1B2D"/>
+                </a:solidFill>
+                <a:latin typeface="Helvetica Neue"/>
+              </a:rPr>
               <a:t>Customers</a:t>
             </a:r>
           </a:p>
@@ -3939,26 +5918,574 @@
       </p:sp>
       <p:sp>
         <p:nvSpPr>
-          <p:cNvPr id="3" name="Content Placeholder 2"/>
-          <p:cNvSpPr>
-            <a:spLocks noGrp="1"/>
-          </p:cNvSpPr>
-          <p:nvPr>
-            <p:ph idx="1"/>
-          </p:nvPr>
-        </p:nvSpPr>
-        <p:spPr/>
-        <p:txBody>
-          <a:bodyPr/>
-          <a:lstStyle/>
-          <a:p>
-            <a:r>
+          <p:cNvPr id="5" name="TextBox 4"/>
+          <p:cNvSpPr txBox="1"/>
+          <p:nvPr/>
+        </p:nvSpPr>
+        <p:spPr>
+          <a:xfrm>
+            <a:off x="762000" y="1809750"/>
+            <a:ext cx="5905500" cy="571500"/>
+          </a:xfrm>
+          <a:prstGeom prst="rect">
+            <a:avLst/>
+          </a:prstGeom>
+          <a:noFill/>
+        </p:spPr>
+        <p:txBody>
+          <a:bodyPr wrap="square">
+            <a:spAutoFit/>
+          </a:bodyPr>
+          <a:lstStyle/>
+          <a:p>
+            <a:pPr>
+              <a:lnSpc>
+                <a:spcPct val="115000"/>
+              </a:lnSpc>
+            </a:pPr>
+            <a:r>
+              <a:rPr sz="3000" b="1">
+                <a:solidFill>
+                  <a:srgbClr val="0F1B2D"/>
+                </a:solidFill>
+                <a:latin typeface="Helvetica Neue"/>
+              </a:rPr>
               <a:t>Globex (2 warehouses), Hooli</a:t>
             </a:r>
           </a:p>
-          <a:p>
-            <a:r>
+        </p:txBody>
+      </p:sp>
+      <p:sp>
+        <p:nvSpPr>
+          <p:cNvPr id="6" name="TextBox 5"/>
+          <p:cNvSpPr txBox="1"/>
+          <p:nvPr/>
+        </p:nvSpPr>
+        <p:spPr>
+          <a:xfrm>
+            <a:off x="762000" y="2381250"/>
+            <a:ext cx="5905500" cy="381000"/>
+          </a:xfrm>
+          <a:prstGeom prst="rect">
+            <a:avLst/>
+          </a:prstGeom>
+          <a:noFill/>
+        </p:spPr>
+        <p:txBody>
+          <a:bodyPr wrap="square">
+            <a:spAutoFit/>
+          </a:bodyPr>
+          <a:lstStyle/>
+          <a:p>
+            <a:pPr>
+              <a:lnSpc>
+                <a:spcPct val="115000"/>
+              </a:lnSpc>
+            </a:pPr>
+            <a:r>
+              <a:rPr sz="2200" b="0">
+                <a:solidFill>
+                  <a:srgbClr val="5D6878"/>
+                </a:solidFill>
+                <a:latin typeface="Helvetica Neue"/>
+              </a:rPr>
               <a:t>Initech: LOI signed, pilot Q1 2027</a:t>
+            </a:r>
+          </a:p>
+        </p:txBody>
+      </p:sp>
+      <p:sp>
+        <p:nvSpPr>
+          <p:cNvPr id="7" name="Rounded Rectangle 6"/>
+          <p:cNvSpPr/>
+          <p:nvPr/>
+        </p:nvSpPr>
+        <p:spPr>
+          <a:xfrm>
+            <a:off x="7239000" y="1714500"/>
+            <a:ext cx="4191000" cy="2857500"/>
+          </a:xfrm>
+          <a:prstGeom prst="roundRect">
+            <a:avLst>
+              <a:gd name="adj" fmla="val 6000"/>
+            </a:avLst>
+          </a:prstGeom>
+          <a:solidFill>
+            <a:srgbClr val="FFFFFF"/>
+          </a:solidFill>
+          <a:ln>
+            <a:solidFill>
+              <a:srgbClr val="E6E2D9"/>
+            </a:solidFill>
+          </a:ln>
+        </p:spPr>
+        <p:style>
+          <a:lnRef idx="1">
+            <a:schemeClr val="accent1"/>
+          </a:lnRef>
+          <a:fillRef idx="3">
+            <a:schemeClr val="accent1"/>
+          </a:fillRef>
+          <a:effectRef idx="2">
+            <a:schemeClr val="accent1"/>
+          </a:effectRef>
+          <a:fontRef idx="minor">
+            <a:schemeClr val="lt1"/>
+          </a:fontRef>
+        </p:style>
+        <p:txBody>
+          <a:bodyPr rtlCol="0" anchor="ctr"/>
+          <a:lstStyle/>
+          <a:p>
+            <a:pPr algn="ctr"/>
+          </a:p>
+        </p:txBody>
+      </p:sp>
+      <p:sp>
+        <p:nvSpPr>
+          <p:cNvPr id="8" name="TextBox 7"/>
+          <p:cNvSpPr txBox="1"/>
+          <p:nvPr/>
+        </p:nvSpPr>
+        <p:spPr>
+          <a:xfrm>
+            <a:off x="7524750" y="1952625"/>
+            <a:ext cx="3714750" cy="2476500"/>
+          </a:xfrm>
+          <a:prstGeom prst="rect">
+            <a:avLst/>
+          </a:prstGeom>
+          <a:noFill/>
+        </p:spPr>
+        <p:txBody>
+          <a:bodyPr wrap="square">
+            <a:spAutoFit/>
+          </a:bodyPr>
+          <a:lstStyle/>
+          <a:p>
+            <a:pPr>
+              <a:lnSpc>
+                <a:spcPct val="130000"/>
+              </a:lnSpc>
+            </a:pPr>
+            <a:r>
+              <a:rPr sz="1700" b="0">
+                <a:solidFill>
+                  <a:srgbClr val="0F1B2D"/>
+                </a:solidFill>
+                <a:latin typeface="Helvetica Neue"/>
+              </a:rPr>
+              <a:t>•  Globex: expansion signed in August</a:t>
+            </a:r>
+          </a:p>
+          <a:p>
+            <a:pPr>
+              <a:lnSpc>
+                <a:spcPct val="130000"/>
+              </a:lnSpc>
+              <a:spcBef>
+                <a:spcPts val="1000"/>
+              </a:spcBef>
+            </a:pPr>
+            <a:r>
+              <a:rPr sz="1700" b="0">
+                <a:solidFill>
+                  <a:srgbClr val="0F1B2D"/>
+                </a:solidFill>
+                <a:latin typeface="Helvetica Neue"/>
+              </a:rPr>
+              <a:t>•  Hooli: labour module beta</a:t>
+            </a:r>
+          </a:p>
+          <a:p>
+            <a:pPr>
+              <a:lnSpc>
+                <a:spcPct val="130000"/>
+              </a:lnSpc>
+              <a:spcBef>
+                <a:spcPts val="1000"/>
+              </a:spcBef>
+            </a:pPr>
+            <a:r>
+              <a:rPr sz="1700" b="0">
+                <a:solidFill>
+                  <a:srgbClr val="0F1B2D"/>
+                </a:solidFill>
+                <a:latin typeface="Helvetica Neue"/>
+              </a:rPr>
+              <a:t>•  Initech: pilot scope agreed</a:t>
+            </a:r>
+          </a:p>
+        </p:txBody>
+      </p:sp>
+      <p:sp>
+        <p:nvSpPr>
+          <p:cNvPr id="9" name="TextBox 8"/>
+          <p:cNvSpPr txBox="1"/>
+          <p:nvPr/>
+        </p:nvSpPr>
+        <p:spPr>
+          <a:xfrm>
+            <a:off x="762000" y="6438900"/>
+            <a:ext cx="5715000" cy="228600"/>
+          </a:xfrm>
+          <a:prstGeom prst="rect">
+            <a:avLst/>
+          </a:prstGeom>
+          <a:noFill/>
+        </p:spPr>
+        <p:txBody>
+          <a:bodyPr wrap="square">
+            <a:spAutoFit/>
+          </a:bodyPr>
+          <a:lstStyle/>
+          <a:p>
+            <a:pPr>
+              <a:lnSpc>
+                <a:spcPct val="115000"/>
+              </a:lnSpc>
+            </a:pPr>
+            <a:r>
+              <a:rPr sz="1000" b="0">
+                <a:solidFill>
+                  <a:srgbClr val="9AA1AB"/>
+                </a:solidFill>
+                <a:latin typeface="Helvetica Neue"/>
+              </a:rPr>
+              <a:t>Acme AI · Board update · Confidential</a:t>
+            </a:r>
+          </a:p>
+        </p:txBody>
+      </p:sp>
+      <p:sp>
+        <p:nvSpPr>
+          <p:cNvPr id="10" name="TextBox 9"/>
+          <p:cNvSpPr txBox="1"/>
+          <p:nvPr/>
+        </p:nvSpPr>
+        <p:spPr>
+          <a:xfrm>
+            <a:off x="10477500" y="6438900"/>
+            <a:ext cx="952500" cy="228600"/>
+          </a:xfrm>
+          <a:prstGeom prst="rect">
+            <a:avLst/>
+          </a:prstGeom>
+          <a:noFill/>
+        </p:spPr>
+        <p:txBody>
+          <a:bodyPr wrap="square">
+            <a:spAutoFit/>
+          </a:bodyPr>
+          <a:lstStyle/>
+          <a:p>
+            <a:pPr algn="r">
+              <a:lnSpc>
+                <a:spcPct val="115000"/>
+              </a:lnSpc>
+            </a:pPr>
+            <a:r>
+              <a:rPr sz="1000" b="0">
+                <a:solidFill>
+                  <a:srgbClr val="9AA1AB"/>
+                </a:solidFill>
+                <a:latin typeface="Helvetica Neue"/>
+              </a:rPr>
+              <a:t>6</a:t>
+            </a:r>
+          </a:p>
+        </p:txBody>
+      </p:sp>
+    </p:spTree>
+  </p:cSld>
+  <p:clrMapOvr>
+    <a:masterClrMapping/>
+  </p:clrMapOvr>
+</p:sld>
+</file>
+
+<file path=ppt/slides/slide7.xml><?xml version="1.0" encoding="utf-8"?>
+<p:sld xmlns:a="http://schemas.openxmlformats.org/drawingml/2006/main" xmlns:p="http://schemas.openxmlformats.org/presentationml/2006/main" xmlns:r="http://schemas.openxmlformats.org/officeDocument/2006/relationships">
+  <p:cSld>
+    <p:spTree>
+      <p:nvGrpSpPr>
+        <p:cNvPr id="1" name=""/>
+        <p:cNvGrpSpPr/>
+        <p:nvPr/>
+      </p:nvGrpSpPr>
+      <p:grpSpPr/>
+      <p:sp>
+        <p:nvSpPr>
+          <p:cNvPr id="2" name="Rectangle 1"/>
+          <p:cNvSpPr/>
+          <p:nvPr/>
+        </p:nvSpPr>
+        <p:spPr>
+          <a:xfrm>
+            <a:off x="0" y="0"/>
+            <a:ext cx="12192000" cy="6858000"/>
+          </a:xfrm>
+          <a:prstGeom prst="rect">
+            <a:avLst/>
+          </a:prstGeom>
+          <a:solidFill>
+            <a:srgbClr val="FBFAF7"/>
+          </a:solidFill>
+          <a:ln>
+            <a:noFill/>
+          </a:ln>
+        </p:spPr>
+        <p:style>
+          <a:lnRef idx="1">
+            <a:schemeClr val="accent1"/>
+          </a:lnRef>
+          <a:fillRef idx="3">
+            <a:schemeClr val="accent1"/>
+          </a:fillRef>
+          <a:effectRef idx="2">
+            <a:schemeClr val="accent1"/>
+          </a:effectRef>
+          <a:fontRef idx="minor">
+            <a:schemeClr val="lt1"/>
+          </a:fontRef>
+        </p:style>
+        <p:txBody>
+          <a:bodyPr rtlCol="0" anchor="ctr"/>
+          <a:lstStyle/>
+          <a:p>
+            <a:pPr algn="ctr"/>
+          </a:p>
+        </p:txBody>
+      </p:sp>
+      <p:sp>
+        <p:nvSpPr>
+          <p:cNvPr id="3" name="TextBox 2"/>
+          <p:cNvSpPr txBox="1"/>
+          <p:nvPr/>
+        </p:nvSpPr>
+        <p:spPr>
+          <a:xfrm>
+            <a:off x="762000" y="533400"/>
+            <a:ext cx="5715000" cy="228600"/>
+          </a:xfrm>
+          <a:prstGeom prst="rect">
+            <a:avLst/>
+          </a:prstGeom>
+          <a:noFill/>
+        </p:spPr>
+        <p:txBody>
+          <a:bodyPr wrap="square">
+            <a:spAutoFit/>
+          </a:bodyPr>
+          <a:lstStyle/>
+          <a:p>
+            <a:pPr>
+              <a:lnSpc>
+                <a:spcPct val="115000"/>
+              </a:lnSpc>
+            </a:pPr>
+            <a:r>
+              <a:rPr sz="1200" b="1">
+                <a:solidFill>
+                  <a:srgbClr val="E0663A"/>
+                </a:solidFill>
+                <a:latin typeface="Helvetica Neue"/>
+              </a:rPr>
+              <a:t>ASKS</a:t>
+            </a:r>
+          </a:p>
+        </p:txBody>
+      </p:sp>
+      <p:sp>
+        <p:nvSpPr>
+          <p:cNvPr id="4" name="TextBox 3"/>
+          <p:cNvSpPr txBox="1"/>
+          <p:nvPr/>
+        </p:nvSpPr>
+        <p:spPr>
+          <a:xfrm>
+            <a:off x="762000" y="800100"/>
+            <a:ext cx="9525000" cy="666750"/>
+          </a:xfrm>
+          <a:prstGeom prst="rect">
+            <a:avLst/>
+          </a:prstGeom>
+          <a:noFill/>
+        </p:spPr>
+        <p:txBody>
+          <a:bodyPr wrap="square">
+            <a:spAutoFit/>
+          </a:bodyPr>
+          <a:lstStyle/>
+          <a:p>
+            <a:pPr>
+              <a:lnSpc>
+                <a:spcPct val="115000"/>
+              </a:lnSpc>
+            </a:pPr>
+            <a:r>
+              <a:rPr sz="3600" b="1">
+                <a:solidFill>
+                  <a:srgbClr val="0F1B2D"/>
+                </a:solidFill>
+                <a:latin typeface="Helvetica Neue"/>
+              </a:rPr>
+              <a:t>What we need from the board</a:t>
+            </a:r>
+          </a:p>
+        </p:txBody>
+      </p:sp>
+      <p:sp>
+        <p:nvSpPr>
+          <p:cNvPr id="5" name="TextBox 4"/>
+          <p:cNvSpPr txBox="1"/>
+          <p:nvPr/>
+        </p:nvSpPr>
+        <p:spPr>
+          <a:xfrm>
+            <a:off x="762000" y="1809750"/>
+            <a:ext cx="9525000" cy="3810000"/>
+          </a:xfrm>
+          <a:prstGeom prst="rect">
+            <a:avLst/>
+          </a:prstGeom>
+          <a:noFill/>
+        </p:spPr>
+        <p:txBody>
+          <a:bodyPr wrap="square">
+            <a:spAutoFit/>
+          </a:bodyPr>
+          <a:lstStyle/>
+          <a:p>
+            <a:pPr>
+              <a:lnSpc>
+                <a:spcPct val="130000"/>
+              </a:lnSpc>
+            </a:pPr>
+            <a:r>
+              <a:rPr sz="2200" b="0">
+                <a:solidFill>
+                  <a:srgbClr val="0F1B2D"/>
+                </a:solidFill>
+                <a:latin typeface="Helvetica Neue"/>
+              </a:rPr>
+              <a:t>•  Intros to operations leaders at mid-market retailers</a:t>
+            </a:r>
+          </a:p>
+          <a:p>
+            <a:pPr>
+              <a:lnSpc>
+                <a:spcPct val="130000"/>
+              </a:lnSpc>
+              <a:spcBef>
+                <a:spcPts val="1000"/>
+              </a:spcBef>
+            </a:pPr>
+            <a:r>
+              <a:rPr sz="2200" b="0">
+                <a:solidFill>
+                  <a:srgbClr val="0F1B2D"/>
+                </a:solidFill>
+                <a:latin typeface="Helvetica Neue"/>
+              </a:rPr>
+              <a:t>•  Two references for the Head of Customer Success search</a:t>
+            </a:r>
+          </a:p>
+          <a:p>
+            <a:pPr>
+              <a:lnSpc>
+                <a:spcPct val="130000"/>
+              </a:lnSpc>
+              <a:spcBef>
+                <a:spcPts val="1000"/>
+              </a:spcBef>
+            </a:pPr>
+            <a:r>
+              <a:rPr sz="2200" b="0">
+                <a:solidFill>
+                  <a:srgbClr val="0F1B2D"/>
+                </a:solidFill>
+                <a:latin typeface="Helvetica Neue"/>
+              </a:rPr>
+              <a:t>•  Feedback on the Series A target list before November</a:t>
+            </a:r>
+          </a:p>
+        </p:txBody>
+      </p:sp>
+      <p:sp>
+        <p:nvSpPr>
+          <p:cNvPr id="6" name="TextBox 5"/>
+          <p:cNvSpPr txBox="1"/>
+          <p:nvPr/>
+        </p:nvSpPr>
+        <p:spPr>
+          <a:xfrm>
+            <a:off x="762000" y="6438900"/>
+            <a:ext cx="5715000" cy="228600"/>
+          </a:xfrm>
+          <a:prstGeom prst="rect">
+            <a:avLst/>
+          </a:prstGeom>
+          <a:noFill/>
+        </p:spPr>
+        <p:txBody>
+          <a:bodyPr wrap="square">
+            <a:spAutoFit/>
+          </a:bodyPr>
+          <a:lstStyle/>
+          <a:p>
+            <a:pPr>
+              <a:lnSpc>
+                <a:spcPct val="115000"/>
+              </a:lnSpc>
+            </a:pPr>
+            <a:r>
+              <a:rPr sz="1000" b="0">
+                <a:solidFill>
+                  <a:srgbClr val="9AA1AB"/>
+                </a:solidFill>
+                <a:latin typeface="Helvetica Neue"/>
+              </a:rPr>
+              <a:t>Acme AI · Board update · Confidential</a:t>
+            </a:r>
+          </a:p>
+        </p:txBody>
+      </p:sp>
+      <p:sp>
+        <p:nvSpPr>
+          <p:cNvPr id="7" name="TextBox 6"/>
+          <p:cNvSpPr txBox="1"/>
+          <p:nvPr/>
+        </p:nvSpPr>
+        <p:spPr>
+          <a:xfrm>
+            <a:off x="10477500" y="6438900"/>
+            <a:ext cx="952500" cy="228600"/>
+          </a:xfrm>
+          <a:prstGeom prst="rect">
+            <a:avLst/>
+          </a:prstGeom>
+          <a:noFill/>
+        </p:spPr>
+        <p:txBody>
+          <a:bodyPr wrap="square">
+            <a:spAutoFit/>
+          </a:bodyPr>
+          <a:lstStyle/>
+          <a:p>
+            <a:pPr algn="r">
+              <a:lnSpc>
+                <a:spcPct val="115000"/>
+              </a:lnSpc>
+            </a:pPr>
+            <a:r>
+              <a:rPr sz="1000" b="0">
+                <a:solidFill>
+                  <a:srgbClr val="9AA1AB"/>
+                </a:solidFill>
+                <a:latin typeface="Helvetica Neue"/>
+              </a:rPr>
+              <a:t>7</a:t>
             </a:r>
           </a:p>
         </p:txBody>

</xml_diff>